<commit_message>
Embed three open-license lamp photos
Co-authored-by: tom948899-jpg <300044775+tom948899-jpg@users.noreply.github.com>
</commit_message>
<xml_diff>
--- a/leuchtstofflampen-praesentation.pptx
+++ b/leuchtstofflampen-praesentation.pptx
@@ -3236,75 +3236,6 @@
           </a:p>
         </p:txBody>
       </p:sp>
-      <p:pic>
-        <p:nvPicPr>
-          <p:cNvPr id="5" name="Quecksilberhaltige Leuchtstoffröhren" descr="fluorescent_tubes.jpg"/>
-          <p:cNvPicPr>
-            <a:picLocks noChangeAspect="1"/>
-          </p:cNvPicPr>
-          <p:nvPr/>
-        </p:nvPicPr>
-        <p:blipFill>
-          <a:blip r:embed="rId2"/>
-          <a:stretch>
-            <a:fillRect/>
-          </a:stretch>
-        </p:blipFill>
-        <p:spPr>
-          <a:xfrm>
-            <a:off x="685800" y="1655064"/>
-            <a:ext cx="5248656" cy="1682495"/>
-          </a:xfrm>
-          <a:prstGeom prst="rect">
-            <a:avLst/>
-          </a:prstGeom>
-        </p:spPr>
-      </p:pic>
-      <p:sp>
-        <p:nvSpPr>
-          <p:cNvPr id="6" name="Rounded Rectangle 5"/>
-          <p:cNvSpPr/>
-          <p:nvPr/>
-        </p:nvSpPr>
-        <p:spPr>
-          <a:xfrm>
-            <a:off x="685800" y="2907791"/>
-            <a:ext cx="5248656" cy="429768"/>
-          </a:xfrm>
-          <a:prstGeom prst="roundRect">
-            <a:avLst>
-              <a:gd name="adj" fmla="val 7000"/>
-            </a:avLst>
-          </a:prstGeom>
-          <a:solidFill>
-            <a:srgbClr val="343A38"/>
-          </a:solidFill>
-          <a:ln>
-            <a:noFill/>
-          </a:ln>
-        </p:spPr>
-        <p:style>
-          <a:lnRef idx="1">
-            <a:schemeClr val="accent1"/>
-          </a:lnRef>
-          <a:fillRef idx="3">
-            <a:schemeClr val="accent1"/>
-          </a:fillRef>
-          <a:effectRef idx="2">
-            <a:schemeClr val="accent1"/>
-          </a:effectRef>
-          <a:fontRef idx="minor">
-            <a:schemeClr val="lt1"/>
-          </a:fontRef>
-        </p:style>
-        <p:txBody>
-          <a:bodyPr rtlCol="0" anchor="ctr"/>
-          <a:lstStyle/>
-          <a:p>
-            <a:pPr algn="ctr"/>
-          </a:p>
-        </p:txBody>
-      </p:sp>
       <p:sp>
         <p:nvSpPr>
           <p:cNvPr id="7" name="TextBox 6"/>
@@ -3336,13 +3267,13 @@
               </a:spcAft>
             </a:pPr>
             <a:r>
-              <a:rPr sz="1000" b="1" i="0">
+              <a:rPr sz="800" b="1" i="0">
                 <a:solidFill>
                   <a:srgbClr val="FFFFFF"/>
                 </a:solidFill>
                 <a:latin typeface="Arial Black"/>
               </a:rPr>
-              <a:t>QUECKSILBERHALTIGE LEUCHTSTOFFRÖHREN</a:t>
+              <a:t>UV-SCHWARZLICHTRÖHREN · SONDERANWENDUNG</a:t>
             </a:r>
           </a:p>
         </p:txBody>
@@ -3394,40 +3325,187 @@
           </a:p>
         </p:txBody>
       </p:sp>
-      <p:pic>
-        <p:nvPicPr>
-          <p:cNvPr id="9" name="LED-Umrüstung an einer Leuchte" descr="led_installation.jpg"/>
-          <p:cNvPicPr>
-            <a:picLocks noChangeAspect="1"/>
-          </p:cNvPicPr>
-          <p:nvPr/>
-        </p:nvPicPr>
-        <p:blipFill>
-          <a:blip r:embed="rId3"/>
-          <a:stretch>
-            <a:fillRect/>
-          </a:stretch>
-        </p:blipFill>
-        <p:spPr>
-          <a:xfrm>
-            <a:off x="6263640" y="1655064"/>
-            <a:ext cx="5248656" cy="1682495"/>
-          </a:xfrm>
-          <a:prstGeom prst="rect">
-            <a:avLst/>
-          </a:prstGeom>
-        </p:spPr>
-      </p:pic>
-      <p:sp>
-        <p:nvSpPr>
-          <p:cNvPr id="10" name="Rounded Rectangle 9"/>
+      <p:sp>
+        <p:nvSpPr>
+          <p:cNvPr id="11" name="TextBox 10"/>
+          <p:cNvSpPr txBox="1"/>
+          <p:nvPr/>
+        </p:nvSpPr>
+        <p:spPr>
+          <a:xfrm>
+            <a:off x="6419088" y="3008375"/>
+            <a:ext cx="4937759" cy="210312"/>
+          </a:xfrm>
+          <a:prstGeom prst="rect">
+            <a:avLst/>
+          </a:prstGeom>
+          <a:noFill/>
+        </p:spPr>
+        <p:txBody>
+          <a:bodyPr wrap="square" lIns="45720" rIns="45720" anchor="t">
+            <a:normAutofit/>
+          </a:bodyPr>
+          <a:lstStyle/>
+          <a:p>
+            <a:pPr algn="l">
+              <a:spcBef>
+                <a:spcPts val="0"/>
+              </a:spcBef>
+              <a:spcAft>
+                <a:spcPts val="0"/>
+              </a:spcAft>
+            </a:pPr>
+            <a:r>
+              <a:rPr sz="800" b="1" i="0">
+                <a:solidFill>
+                  <a:srgbClr val="FFFFFF"/>
+                </a:solidFill>
+                <a:latin typeface="Arial Black"/>
+              </a:rPr>
+              <a:t>UV-C-QUECKSILBERLAMPE · SPEZIALANWENDUNG</a:t>
+            </a:r>
+          </a:p>
+        </p:txBody>
+      </p:sp>
+      <p:sp>
+        <p:nvSpPr>
+          <p:cNvPr id="12" name="Rounded Rectangle 11"/>
           <p:cNvSpPr/>
           <p:nvPr/>
         </p:nvSpPr>
         <p:spPr>
           <a:xfrm>
-            <a:off x="6263640" y="2907791"/>
-            <a:ext cx="5248656" cy="429768"/>
+            <a:off x="658368" y="3639312"/>
+            <a:ext cx="5303520" cy="1856231"/>
+          </a:xfrm>
+          <a:prstGeom prst="roundRect">
+            <a:avLst>
+              <a:gd name="adj" fmla="val 7000"/>
+            </a:avLst>
+          </a:prstGeom>
+          <a:solidFill>
+            <a:srgbClr val="16834D"/>
+          </a:solidFill>
+          <a:ln>
+            <a:noFill/>
+          </a:ln>
+        </p:spPr>
+        <p:style>
+          <a:lnRef idx="1">
+            <a:schemeClr val="accent1"/>
+          </a:lnRef>
+          <a:fillRef idx="3">
+            <a:schemeClr val="accent1"/>
+          </a:fillRef>
+          <a:effectRef idx="2">
+            <a:schemeClr val="accent1"/>
+          </a:effectRef>
+          <a:fontRef idx="minor">
+            <a:schemeClr val="lt1"/>
+          </a:fontRef>
+        </p:style>
+        <p:txBody>
+          <a:bodyPr rtlCol="0" anchor="ctr"/>
+          <a:lstStyle/>
+          <a:p>
+            <a:pPr algn="ctr"/>
+          </a:p>
+        </p:txBody>
+      </p:sp>
+      <p:sp>
+        <p:nvSpPr>
+          <p:cNvPr id="13" name="TextBox 12"/>
+          <p:cNvSpPr txBox="1"/>
+          <p:nvPr/>
+        </p:nvSpPr>
+        <p:spPr>
+          <a:xfrm>
+            <a:off x="859536" y="3822191"/>
+            <a:ext cx="4901183" cy="438912"/>
+          </a:xfrm>
+          <a:prstGeom prst="rect">
+            <a:avLst/>
+          </a:prstGeom>
+          <a:noFill/>
+        </p:spPr>
+        <p:txBody>
+          <a:bodyPr wrap="square" lIns="45720" rIns="45720" anchor="t">
+            <a:normAutofit/>
+          </a:bodyPr>
+          <a:lstStyle/>
+          <a:p>
+            <a:pPr algn="l">
+              <a:spcBef>
+                <a:spcPts val="0"/>
+              </a:spcBef>
+              <a:spcAft>
+                <a:spcPts val="0"/>
+              </a:spcAft>
+            </a:pPr>
+            <a:r>
+              <a:rPr sz="1600" b="1" i="0">
+                <a:solidFill>
+                  <a:srgbClr val="FFFFFF"/>
+                </a:solidFill>
+                <a:latin typeface="Arial Black"/>
+              </a:rPr>
+              <a:t>WAS DIE EU-REGEL SAGT</a:t>
+            </a:r>
+          </a:p>
+        </p:txBody>
+      </p:sp>
+      <p:sp>
+        <p:nvSpPr>
+          <p:cNvPr id="14" name="TextBox 13"/>
+          <p:cNvSpPr txBox="1"/>
+          <p:nvPr/>
+        </p:nvSpPr>
+        <p:spPr>
+          <a:xfrm>
+            <a:off x="859536" y="4343400"/>
+            <a:ext cx="4901183" cy="1024127"/>
+          </a:xfrm>
+          <a:prstGeom prst="rect">
+            <a:avLst/>
+          </a:prstGeom>
+          <a:noFill/>
+        </p:spPr>
+        <p:txBody>
+          <a:bodyPr wrap="square" lIns="45720" rIns="45720" anchor="t">
+            <a:normAutofit/>
+          </a:bodyPr>
+          <a:lstStyle/>
+          <a:p>
+            <a:pPr algn="l">
+              <a:spcBef>
+                <a:spcPts val="0"/>
+              </a:spcBef>
+              <a:spcAft>
+                <a:spcPts val="0"/>
+              </a:spcAft>
+            </a:pPr>
+            <a:r>
+              <a:rPr sz="1200" b="0" i="0">
+                <a:solidFill>
+                  <a:srgbClr val="FFFFFF"/>
+                </a:solidFill>
+                <a:latin typeface="Arial"/>
+              </a:rPr>
+              <a:t>Für T5/T8-Röhren zur Allgemeinbeleuchtung endete eine RoHS-Ausnahme am 24.08.2023. Das ist kein pauschaler Austauschzwang für jede vorhandene Leuchte.</a:t>
+            </a:r>
+          </a:p>
+        </p:txBody>
+      </p:sp>
+      <p:sp>
+        <p:nvSpPr>
+          <p:cNvPr id="15" name="Rounded Rectangle 14"/>
+          <p:cNvSpPr/>
+          <p:nvPr/>
+        </p:nvSpPr>
+        <p:spPr>
+          <a:xfrm>
+            <a:off x="6236208" y="3639312"/>
+            <a:ext cx="5303520" cy="1856231"/>
           </a:xfrm>
           <a:prstGeom prst="roundRect">
             <a:avLst>
@@ -3465,56 +3543,182 @@
       </p:sp>
       <p:sp>
         <p:nvSpPr>
-          <p:cNvPr id="11" name="TextBox 10"/>
-          <p:cNvSpPr txBox="1"/>
-          <p:nvPr/>
-        </p:nvSpPr>
-        <p:spPr>
-          <a:xfrm>
-            <a:off x="6419088" y="3008375"/>
-            <a:ext cx="4937759" cy="210312"/>
-          </a:xfrm>
-          <a:prstGeom prst="rect">
-            <a:avLst/>
-          </a:prstGeom>
-          <a:noFill/>
-        </p:spPr>
-        <p:txBody>
-          <a:bodyPr wrap="square" lIns="45720" rIns="45720" anchor="t">
-            <a:normAutofit/>
-          </a:bodyPr>
-          <a:lstStyle/>
-          <a:p>
-            <a:pPr algn="l">
-              <a:spcBef>
-                <a:spcPts val="0"/>
-              </a:spcBef>
-              <a:spcAft>
-                <a:spcPts val="0"/>
-              </a:spcAft>
-            </a:pPr>
-            <a:r>
-              <a:rPr sz="1000" b="1" i="0">
+          <p:cNvPr id="16" name="TextBox 15"/>
+          <p:cNvSpPr txBox="1"/>
+          <p:nvPr/>
+        </p:nvSpPr>
+        <p:spPr>
+          <a:xfrm>
+            <a:off x="6437376" y="3822191"/>
+            <a:ext cx="4901183" cy="438912"/>
+          </a:xfrm>
+          <a:prstGeom prst="rect">
+            <a:avLst/>
+          </a:prstGeom>
+          <a:noFill/>
+        </p:spPr>
+        <p:txBody>
+          <a:bodyPr wrap="square" lIns="45720" rIns="45720" anchor="t">
+            <a:normAutofit/>
+          </a:bodyPr>
+          <a:lstStyle/>
+          <a:p>
+            <a:pPr algn="l">
+              <a:spcBef>
+                <a:spcPts val="0"/>
+              </a:spcBef>
+              <a:spcAft>
+                <a:spcPts val="0"/>
+              </a:spcAft>
+            </a:pPr>
+            <a:r>
+              <a:rPr sz="1600" b="1" i="0">
                 <a:solidFill>
                   <a:srgbClr val="FFFFFF"/>
                 </a:solidFill>
                 <a:latin typeface="Arial Black"/>
               </a:rPr>
-              <a:t>LED-UMRÜSTUNG AN EINER LEUCHTE</a:t>
-            </a:r>
-          </a:p>
-        </p:txBody>
-      </p:sp>
-      <p:sp>
-        <p:nvSpPr>
-          <p:cNvPr id="12" name="Rounded Rectangle 11"/>
+              <a:t>RETROFIT &amp; ENERGIE</a:t>
+            </a:r>
+          </a:p>
+        </p:txBody>
+      </p:sp>
+      <p:sp>
+        <p:nvSpPr>
+          <p:cNvPr id="17" name="TextBox 16"/>
+          <p:cNvSpPr txBox="1"/>
+          <p:nvPr/>
+        </p:nvSpPr>
+        <p:spPr>
+          <a:xfrm>
+            <a:off x="6437376" y="4343400"/>
+            <a:ext cx="4901183" cy="1024127"/>
+          </a:xfrm>
+          <a:prstGeom prst="rect">
+            <a:avLst/>
+          </a:prstGeom>
+          <a:noFill/>
+        </p:spPr>
+        <p:txBody>
+          <a:bodyPr wrap="square" lIns="45720" rIns="45720" anchor="t">
+            <a:normAutofit/>
+          </a:bodyPr>
+          <a:lstStyle/>
+          <a:p>
+            <a:pPr algn="l">
+              <a:spcBef>
+                <a:spcPts val="0"/>
+              </a:spcBef>
+              <a:spcAft>
+                <a:spcPts val="0"/>
+              </a:spcAft>
+            </a:pPr>
+            <a:r>
+              <a:rPr sz="1200" b="0" i="0">
+                <a:solidFill>
+                  <a:srgbClr val="FFFFFF"/>
+                </a:solidFill>
+                <a:latin typeface="Arial"/>
+              </a:rPr>
+              <a:t>LED kann weniger Strom brauchen – bei passender Lichtmenge und kompatibler Leuchte. Sockel, Vorschaltgerät und Produktangaben vorher prüfen.</a:t>
+            </a:r>
+          </a:p>
+        </p:txBody>
+      </p:sp>
+      <p:sp>
+        <p:nvSpPr>
+          <p:cNvPr id="18" name="TextBox 17"/>
+          <p:cNvSpPr txBox="1"/>
+          <p:nvPr/>
+        </p:nvSpPr>
+        <p:spPr>
+          <a:xfrm>
+            <a:off x="676656" y="5925312"/>
+            <a:ext cx="10789920" cy="237744"/>
+          </a:xfrm>
+          <a:prstGeom prst="rect">
+            <a:avLst/>
+          </a:prstGeom>
+          <a:noFill/>
+        </p:spPr>
+        <p:txBody>
+          <a:bodyPr wrap="square" lIns="45720" rIns="45720" anchor="t">
+            <a:normAutofit/>
+          </a:bodyPr>
+          <a:lstStyle/>
+          <a:p>
+            <a:pPr algn="l">
+              <a:spcBef>
+                <a:spcPts val="0"/>
+              </a:spcBef>
+              <a:spcAft>
+                <a:spcPts val="0"/>
+              </a:spcAft>
+            </a:pPr>
+            <a:r>
+              <a:rPr sz="1000" b="0" i="0">
+                <a:solidFill>
+                  <a:srgbClr val="646862"/>
+                </a:solidFill>
+                <a:latin typeface="Arial"/>
+              </a:rPr>
+              <a:t>Faktenstand: September 2026  ·  Beispielsimulationen auf Folie 7</a:t>
+            </a:r>
+          </a:p>
+        </p:txBody>
+      </p:sp>
+      <p:sp>
+        <p:nvSpPr>
+          <p:cNvPr id="19" name="TextBox 18"/>
+          <p:cNvSpPr txBox="1"/>
+          <p:nvPr/>
+        </p:nvSpPr>
+        <p:spPr>
+          <a:xfrm>
+            <a:off x="10652760" y="5925312"/>
+            <a:ext cx="868680" cy="210312"/>
+          </a:xfrm>
+          <a:prstGeom prst="rect">
+            <a:avLst/>
+          </a:prstGeom>
+          <a:noFill/>
+        </p:spPr>
+        <p:txBody>
+          <a:bodyPr wrap="square" lIns="45720" rIns="45720" anchor="t">
+            <a:normAutofit/>
+          </a:bodyPr>
+          <a:lstStyle/>
+          <a:p>
+            <a:pPr algn="r">
+              <a:spcBef>
+                <a:spcPts val="0"/>
+              </a:spcBef>
+              <a:spcAft>
+                <a:spcPts val="0"/>
+              </a:spcAft>
+            </a:pPr>
+            <a:r>
+              <a:rPr sz="900" b="1" i="0">
+                <a:solidFill>
+                  <a:srgbClr val="646862"/>
+                </a:solidFill>
+                <a:latin typeface="Arial"/>
+              </a:rPr>
+              <a:t>01  /  10</a:t>
+            </a:r>
+          </a:p>
+        </p:txBody>
+      </p:sp>
+      <p:sp>
+        <p:nvSpPr>
+          <p:cNvPr id="6" name="Rounded Rectangle 5"/>
           <p:cNvSpPr/>
           <p:nvPr/>
         </p:nvSpPr>
         <p:spPr>
           <a:xfrm>
-            <a:off x="658368" y="3639312"/>
-            <a:ext cx="5303520" cy="1856231"/>
+            <a:off x="685800" y="2907791"/>
+            <a:ext cx="5248656" cy="429768"/>
           </a:xfrm>
           <a:prstGeom prst="roundRect">
             <a:avLst>
@@ -3522,7 +3726,7 @@
             </a:avLst>
           </a:prstGeom>
           <a:solidFill>
-            <a:srgbClr val="16834D"/>
+            <a:srgbClr val="343A38"/>
           </a:solidFill>
           <a:ln>
             <a:noFill/>
@@ -3550,100 +3754,40 @@
           </a:p>
         </p:txBody>
       </p:sp>
-      <p:sp>
-        <p:nvSpPr>
-          <p:cNvPr id="13" name="TextBox 12"/>
-          <p:cNvSpPr txBox="1"/>
-          <p:nvPr/>
-        </p:nvSpPr>
-        <p:spPr>
-          <a:xfrm>
-            <a:off x="859536" y="3822191"/>
-            <a:ext cx="4901183" cy="438912"/>
-          </a:xfrm>
-          <a:prstGeom prst="rect">
-            <a:avLst/>
-          </a:prstGeom>
-          <a:noFill/>
-        </p:spPr>
-        <p:txBody>
-          <a:bodyPr wrap="square" lIns="45720" rIns="45720" anchor="t">
-            <a:normAutofit/>
-          </a:bodyPr>
-          <a:lstStyle/>
-          <a:p>
-            <a:pPr algn="l">
-              <a:spcBef>
-                <a:spcPts val="0"/>
-              </a:spcBef>
-              <a:spcAft>
-                <a:spcPts val="0"/>
-              </a:spcAft>
-            </a:pPr>
-            <a:r>
-              <a:rPr sz="1600" b="1" i="0">
-                <a:solidFill>
-                  <a:srgbClr val="FFFFFF"/>
-                </a:solidFill>
-                <a:latin typeface="Arial Black"/>
-              </a:rPr>
-              <a:t>WAS DIE EU-REGEL SAGT</a:t>
-            </a:r>
-          </a:p>
-        </p:txBody>
-      </p:sp>
-      <p:sp>
-        <p:nvSpPr>
-          <p:cNvPr id="14" name="TextBox 13"/>
-          <p:cNvSpPr txBox="1"/>
-          <p:nvPr/>
-        </p:nvSpPr>
-        <p:spPr>
-          <a:xfrm>
-            <a:off x="859536" y="4343400"/>
-            <a:ext cx="4901183" cy="1024127"/>
-          </a:xfrm>
-          <a:prstGeom prst="rect">
-            <a:avLst/>
-          </a:prstGeom>
-          <a:noFill/>
-        </p:spPr>
-        <p:txBody>
-          <a:bodyPr wrap="square" lIns="45720" rIns="45720" anchor="t">
-            <a:normAutofit/>
-          </a:bodyPr>
-          <a:lstStyle/>
-          <a:p>
-            <a:pPr algn="l">
-              <a:spcBef>
-                <a:spcPts val="0"/>
-              </a:spcBef>
-              <a:spcAft>
-                <a:spcPts val="0"/>
-              </a:spcAft>
-            </a:pPr>
-            <a:r>
-              <a:rPr sz="1200" b="0" i="0">
-                <a:solidFill>
-                  <a:srgbClr val="FFFFFF"/>
-                </a:solidFill>
-                <a:latin typeface="Arial"/>
-              </a:rPr>
-              <a:t>Für T5/T8-Röhren zur Allgemeinbeleuchtung endete eine RoHS-Ausnahme am 24.08.2023. Das ist kein pauschaler Austauschzwang für jede vorhandene Leuchte.</a:t>
-            </a:r>
-          </a:p>
-        </p:txBody>
-      </p:sp>
-      <p:sp>
-        <p:nvSpPr>
-          <p:cNvPr id="15" name="Rounded Rectangle 14"/>
+      <p:pic>
+        <p:nvPicPr>
+          <p:cNvPr id="20" name="UV-SCHWARZLICHTRÖHREN · SONDERANWENDUNG" descr="UV-SCHWARZLICHTRÖHREN · SONDERANWENDUNG"/>
+          <p:cNvPicPr>
+            <a:picLocks noChangeAspect="1"/>
+          </p:cNvPicPr>
+          <p:nvPr/>
+        </p:nvPicPr>
+        <p:blipFill>
+          <a:blip r:embed="rId4"/>
+          <a:stretch>
+            <a:fillRect/>
+          </a:stretch>
+        </p:blipFill>
+        <p:spPr>
+          <a:xfrm>
+            <a:off x="685800" y="1655064"/>
+            <a:ext cx="5248656" cy="1682495"/>
+          </a:xfrm>
+          <a:prstGeom prst="rect">
+            <a:avLst/>
+          </a:prstGeom>
+        </p:spPr>
+      </p:pic>
+      <p:sp>
+        <p:nvSpPr>
+          <p:cNvPr id="10" name="Rounded Rectangle 9"/>
           <p:cNvSpPr/>
           <p:nvPr/>
         </p:nvSpPr>
         <p:spPr>
           <a:xfrm>
-            <a:off x="6236208" y="3639312"/>
-            <a:ext cx="5303520" cy="1856231"/>
+            <a:off x="6263640" y="2907791"/>
+            <a:ext cx="5248656" cy="429768"/>
           </a:xfrm>
           <a:prstGeom prst="roundRect">
             <a:avLst>
@@ -3679,174 +3823,30 @@
           </a:p>
         </p:txBody>
       </p:sp>
-      <p:sp>
-        <p:nvSpPr>
-          <p:cNvPr id="16" name="TextBox 15"/>
-          <p:cNvSpPr txBox="1"/>
-          <p:nvPr/>
-        </p:nvSpPr>
-        <p:spPr>
-          <a:xfrm>
-            <a:off x="6437376" y="3822191"/>
-            <a:ext cx="4901183" cy="438912"/>
-          </a:xfrm>
-          <a:prstGeom prst="rect">
-            <a:avLst/>
-          </a:prstGeom>
-          <a:noFill/>
-        </p:spPr>
-        <p:txBody>
-          <a:bodyPr wrap="square" lIns="45720" rIns="45720" anchor="t">
-            <a:normAutofit/>
-          </a:bodyPr>
-          <a:lstStyle/>
-          <a:p>
-            <a:pPr algn="l">
-              <a:spcBef>
-                <a:spcPts val="0"/>
-              </a:spcBef>
-              <a:spcAft>
-                <a:spcPts val="0"/>
-              </a:spcAft>
-            </a:pPr>
-            <a:r>
-              <a:rPr sz="1600" b="1" i="0">
-                <a:solidFill>
-                  <a:srgbClr val="FFFFFF"/>
-                </a:solidFill>
-                <a:latin typeface="Arial Black"/>
-              </a:rPr>
-              <a:t>RETROFIT &amp; ENERGIE</a:t>
-            </a:r>
-          </a:p>
-        </p:txBody>
-      </p:sp>
-      <p:sp>
-        <p:nvSpPr>
-          <p:cNvPr id="17" name="TextBox 16"/>
-          <p:cNvSpPr txBox="1"/>
-          <p:nvPr/>
-        </p:nvSpPr>
-        <p:spPr>
-          <a:xfrm>
-            <a:off x="6437376" y="4343400"/>
-            <a:ext cx="4901183" cy="1024127"/>
-          </a:xfrm>
-          <a:prstGeom prst="rect">
-            <a:avLst/>
-          </a:prstGeom>
-          <a:noFill/>
-        </p:spPr>
-        <p:txBody>
-          <a:bodyPr wrap="square" lIns="45720" rIns="45720" anchor="t">
-            <a:normAutofit/>
-          </a:bodyPr>
-          <a:lstStyle/>
-          <a:p>
-            <a:pPr algn="l">
-              <a:spcBef>
-                <a:spcPts val="0"/>
-              </a:spcBef>
-              <a:spcAft>
-                <a:spcPts val="0"/>
-              </a:spcAft>
-            </a:pPr>
-            <a:r>
-              <a:rPr sz="1200" b="0" i="0">
-                <a:solidFill>
-                  <a:srgbClr val="FFFFFF"/>
-                </a:solidFill>
-                <a:latin typeface="Arial"/>
-              </a:rPr>
-              <a:t>LED kann weniger Strom brauchen – bei passender Lichtmenge und kompatibler Leuchte. Sockel, Vorschaltgerät und Produktangaben vorher prüfen.</a:t>
-            </a:r>
-          </a:p>
-        </p:txBody>
-      </p:sp>
-      <p:sp>
-        <p:nvSpPr>
-          <p:cNvPr id="18" name="TextBox 17"/>
-          <p:cNvSpPr txBox="1"/>
-          <p:nvPr/>
-        </p:nvSpPr>
-        <p:spPr>
-          <a:xfrm>
-            <a:off x="676656" y="5925312"/>
-            <a:ext cx="10789920" cy="237744"/>
-          </a:xfrm>
-          <a:prstGeom prst="rect">
-            <a:avLst/>
-          </a:prstGeom>
-          <a:noFill/>
-        </p:spPr>
-        <p:txBody>
-          <a:bodyPr wrap="square" lIns="45720" rIns="45720" anchor="t">
-            <a:normAutofit/>
-          </a:bodyPr>
-          <a:lstStyle/>
-          <a:p>
-            <a:pPr algn="l">
-              <a:spcBef>
-                <a:spcPts val="0"/>
-              </a:spcBef>
-              <a:spcAft>
-                <a:spcPts val="0"/>
-              </a:spcAft>
-            </a:pPr>
-            <a:r>
-              <a:rPr sz="1000" b="0" i="0">
-                <a:solidFill>
-                  <a:srgbClr val="646862"/>
-                </a:solidFill>
-                <a:latin typeface="Arial"/>
-              </a:rPr>
-              <a:t>Faktenstand: September 2026  ·  Beispielsimulationen auf Folie 7</a:t>
-            </a:r>
-          </a:p>
-        </p:txBody>
-      </p:sp>
-      <p:sp>
-        <p:nvSpPr>
-          <p:cNvPr id="19" name="TextBox 18"/>
-          <p:cNvSpPr txBox="1"/>
-          <p:nvPr/>
-        </p:nvSpPr>
-        <p:spPr>
-          <a:xfrm>
-            <a:off x="10652760" y="5925312"/>
-            <a:ext cx="868680" cy="210312"/>
-          </a:xfrm>
-          <a:prstGeom prst="rect">
-            <a:avLst/>
-          </a:prstGeom>
-          <a:noFill/>
-        </p:spPr>
-        <p:txBody>
-          <a:bodyPr wrap="square" lIns="45720" rIns="45720" anchor="t">
-            <a:normAutofit/>
-          </a:bodyPr>
-          <a:lstStyle/>
-          <a:p>
-            <a:pPr algn="r">
-              <a:spcBef>
-                <a:spcPts val="0"/>
-              </a:spcBef>
-              <a:spcAft>
-                <a:spcPts val="0"/>
-              </a:spcAft>
-            </a:pPr>
-            <a:r>
-              <a:rPr sz="900" b="1" i="0">
-                <a:solidFill>
-                  <a:srgbClr val="646862"/>
-                </a:solidFill>
-                <a:latin typeface="Arial"/>
-              </a:rPr>
-              <a:t>01  /  10</a:t>
-            </a:r>
-          </a:p>
-        </p:txBody>
-      </p:sp>
+      <p:pic>
+        <p:nvPicPr>
+          <p:cNvPr id="21" name="UV-C-QUECKSILBERLAMPE · SPEZIALANWENDUNG" descr="UV-C-QUECKSILBERLAMPE · SPEZIALANWENDUNG"/>
+          <p:cNvPicPr>
+            <a:picLocks noChangeAspect="1"/>
+          </p:cNvPicPr>
+          <p:nvPr/>
+        </p:nvPicPr>
+        <p:blipFill>
+          <a:blip r:embed="rId5"/>
+          <a:stretch>
+            <a:fillRect/>
+          </a:stretch>
+        </p:blipFill>
+        <p:spPr>
+          <a:xfrm>
+            <a:off x="6263640" y="1655064"/>
+            <a:ext cx="5248656" cy="1682495"/>
+          </a:xfrm>
+          <a:prstGeom prst="rect">
+            <a:avLst/>
+          </a:prstGeom>
+        </p:spPr>
+      </p:pic>
     </p:spTree>
   </p:cSld>
   <p:clrMapOvr>
@@ -4844,7 +4844,78 @@
                 </a:solidFill>
                 <a:latin typeface="Arial"/>
               </a:rPr>
-              <a:t>Faktenstand: September 2026. Eigene schematische Illustrationen. Simulationen mit ausdrücklich angenommenen Eingaben; keine Produkt- oder Einspargarantie.</a:t>
+              <a:t>Faktenstand: September 2026. Fotos aus Wikimedia Commons, zugeschnitten: Chetvorno, „Two black light fluorescent tubes.jpg“ und „Two black light lamps.jpg“ (CC0 1.0); Atlant, „Germicidal Lamp 1.jpg“ (CC BY 2.5).</a:t>
+            </a:r>
+          </a:p>
+        </p:txBody>
+      </p:sp>
+      <p:sp>
+        <p:nvSpPr>
+          <p:cNvPr id="25" name="TextBox 24"/>
+          <p:cNvSpPr txBox="1"/>
+          <p:nvPr/>
+        </p:nvSpPr>
+        <p:spPr>
+          <a:xfrm>
+            <a:off x="749808" y="5925312"/>
+            <a:ext cx="10652760" cy="402336"/>
+          </a:xfrm>
+          <a:prstGeom prst="rect">
+            <a:avLst/>
+          </a:prstGeom>
+          <a:noFill/>
+        </p:spPr>
+        <p:txBody>
+          <a:bodyPr wrap="square" lIns="0" rIns="0" tIns="0" bIns="0">
+            <a:spAutoFit/>
+          </a:bodyPr>
+          <a:lstStyle/>
+          <a:p>
+            <a:pPr>
+              <a:spcAft>
+                <a:spcPts val="0"/>
+              </a:spcAft>
+            </a:pPr>
+            <a:r>
+              <a:rPr sz="650">
+                <a:solidFill>
+                  <a:srgbClr val="646862"/>
+                </a:solidFill>
+                <a:latin typeface="Arial"/>
+              </a:rPr>
+              <a:t>Foto 1: Chetvorno, Two black light fluorescent tubes.jpg — CC0 1.0 — commons.wikimedia.org/wiki/File:Two_black_light_fluorescent_tubes.jpg</a:t>
+            </a:r>
+          </a:p>
+          <a:p>
+            <a:pPr>
+              <a:spcAft>
+                <a:spcPts val="0"/>
+              </a:spcAft>
+            </a:pPr>
+            <a:r>
+              <a:rPr sz="650">
+                <a:solidFill>
+                  <a:srgbClr val="646862"/>
+                </a:solidFill>
+                <a:latin typeface="Arial"/>
+              </a:rPr>
+              <a:t>Foto 2: Chetvorno, Two black light lamps.jpg — CC0 1.0 — commons.wikimedia.org/wiki/File:Two_black_light_lamps.jpg</a:t>
+            </a:r>
+          </a:p>
+          <a:p>
+            <a:pPr>
+              <a:spcAft>
+                <a:spcPts val="0"/>
+              </a:spcAft>
+            </a:pPr>
+            <a:r>
+              <a:rPr sz="650">
+                <a:solidFill>
+                  <a:srgbClr val="646862"/>
+                </a:solidFill>
+                <a:latin typeface="Arial"/>
+              </a:rPr>
+              <a:t>Foto 3: Atlant, Germicidal Lamp 1.jpg — CC BY 2.5 — commons.wikimedia.org/wiki/File:Germicidal_Lamp_1.jpg (zugeschnitten)</a:t>
             </a:r>
           </a:p>
         </p:txBody>
@@ -5936,7 +6007,83 @@
                 </a:solidFill>
                 <a:latin typeface="Arial"/>
               </a:rPr>
-              <a:t>Je nach Bauart startet die Lampe mit Starter oder elektronischer Vorschalttechnik.</a:t>
+              <a:t>Vorsicht: Die Fotos zeigen UV-Speziallampen, nicht gewöhnliche Raumbeleuchtung. Normale Leuchtstofflampen nutzen denselben Grundmechanismus, aber eine andere Leuchtschicht.</a:t>
+            </a:r>
+          </a:p>
+        </p:txBody>
+      </p:sp>
+      <p:pic>
+        <p:nvPicPr>
+          <p:cNvPr id="27" name="Leuchtstofflampen im Einsatz · UV-Schwarzlicht" descr="Leuchtstofflampen im Einsatz · UV-Schwarzlicht"/>
+          <p:cNvPicPr>
+            <a:picLocks noChangeAspect="1"/>
+          </p:cNvPicPr>
+          <p:nvPr/>
+        </p:nvPicPr>
+        <p:blipFill>
+          <a:blip r:embed="rId2"/>
+          <a:stretch>
+            <a:fillRect/>
+          </a:stretch>
+        </p:blipFill>
+        <p:spPr>
+          <a:xfrm>
+            <a:off x="7973568" y="5074920"/>
+            <a:ext cx="3456432" cy="841248"/>
+          </a:xfrm>
+          <a:prstGeom prst="rect">
+            <a:avLst/>
+          </a:prstGeom>
+        </p:spPr>
+      </p:pic>
+      <p:sp>
+        <p:nvSpPr>
+          <p:cNvPr id="28" name="Rectangle 27"/>
+          <p:cNvSpPr/>
+          <p:nvPr/>
+        </p:nvSpPr>
+        <p:spPr>
+          <a:xfrm>
+            <a:off x="7973568" y="5689031"/>
+            <a:ext cx="3456432" cy="227136"/>
+          </a:xfrm>
+          <a:prstGeom prst="rect">
+            <a:avLst/>
+          </a:prstGeom>
+          <a:solidFill>
+            <a:srgbClr val="174DB4"/>
+          </a:solidFill>
+          <a:ln>
+            <a:noFill/>
+          </a:ln>
+        </p:spPr>
+        <p:style>
+          <a:lnRef idx="1">
+            <a:schemeClr val="accent1"/>
+          </a:lnRef>
+          <a:fillRef idx="3">
+            <a:schemeClr val="accent1"/>
+          </a:fillRef>
+          <a:effectRef idx="2">
+            <a:schemeClr val="accent1"/>
+          </a:effectRef>
+          <a:fontRef idx="minor">
+            <a:schemeClr val="lt1"/>
+          </a:fontRef>
+        </p:style>
+        <p:txBody>
+          <a:bodyPr rtlCol="0" anchor="ctr" wrap="none" lIns="73152" rIns="36576" tIns="13716" bIns="0"/>
+          <a:lstStyle/>
+          <a:p>
+            <a:pPr algn="l"/>
+            <a:r>
+              <a:rPr sz="800" b="1">
+                <a:solidFill>
+                  <a:srgbClr val="FFFFFF"/>
+                </a:solidFill>
+                <a:latin typeface="Arial"/>
+              </a:rPr>
+              <a:t>LEUCHTSTOFFLAMPEN IM EINSATZ · UV-SCHWARZLICHT</a:t>
             </a:r>
           </a:p>
         </p:txBody>
@@ -7439,7 +7586,83 @@
                 </a:solidFill>
                 <a:latin typeface="Arial"/>
               </a:rPr>
-              <a:t>Quelle: Umweltbundesamt, „Wohin mit kaputten Lampen?“</a:t>
+              <a:t>Quelle: Umweltbundesamt, „Wohin mit kaputten Lampen?“ · Das Foto zeigt UV-Schwarzlicht-Sonderlampen.</a:t>
+            </a:r>
+          </a:p>
+        </p:txBody>
+      </p:sp>
+      <p:pic>
+        <p:nvPicPr>
+          <p:cNvPr id="20" name="Echte UV-Leuchtstoffröhren · Sonderanwendung" descr="Echte UV-Leuchtstoffröhren · Sonderanwendung"/>
+          <p:cNvPicPr>
+            <a:picLocks noChangeAspect="1"/>
+          </p:cNvPicPr>
+          <p:nvPr/>
+        </p:nvPicPr>
+        <p:blipFill>
+          <a:blip r:embed="rId2"/>
+          <a:stretch>
+            <a:fillRect/>
+          </a:stretch>
+        </p:blipFill>
+        <p:spPr>
+          <a:xfrm>
+            <a:off x="7726679" y="5230368"/>
+            <a:ext cx="3675887" cy="850392"/>
+          </a:xfrm>
+          <a:prstGeom prst="rect">
+            <a:avLst/>
+          </a:prstGeom>
+        </p:spPr>
+      </p:pic>
+      <p:sp>
+        <p:nvSpPr>
+          <p:cNvPr id="21" name="Rectangle 20"/>
+          <p:cNvSpPr/>
+          <p:nvPr/>
+        </p:nvSpPr>
+        <p:spPr>
+          <a:xfrm>
+            <a:off x="7726679" y="5852159"/>
+            <a:ext cx="3675887" cy="228600"/>
+          </a:xfrm>
+          <a:prstGeom prst="rect">
+            <a:avLst/>
+          </a:prstGeom>
+          <a:solidFill>
+            <a:srgbClr val="16834D"/>
+          </a:solidFill>
+          <a:ln>
+            <a:noFill/>
+          </a:ln>
+        </p:spPr>
+        <p:style>
+          <a:lnRef idx="1">
+            <a:schemeClr val="accent1"/>
+          </a:lnRef>
+          <a:fillRef idx="3">
+            <a:schemeClr val="accent1"/>
+          </a:fillRef>
+          <a:effectRef idx="2">
+            <a:schemeClr val="accent1"/>
+          </a:effectRef>
+          <a:fontRef idx="minor">
+            <a:schemeClr val="lt1"/>
+          </a:fontRef>
+        </p:style>
+        <p:txBody>
+          <a:bodyPr rtlCol="0" anchor="ctr" wrap="none" lIns="73152" rIns="36576" tIns="13716" bIns="0"/>
+          <a:lstStyle/>
+          <a:p>
+            <a:pPr algn="l"/>
+            <a:r>
+              <a:rPr sz="800" b="1">
+                <a:solidFill>
+                  <a:srgbClr val="FFFFFF"/>
+                </a:solidFill>
+                <a:latin typeface="Arial"/>
+              </a:rPr>
+              <a:t>ECHTE UV-LEUCHTSTOFFRÖHREN · SONDERANWENDUNG</a:t>
             </a:r>
           </a:p>
         </p:txBody>
@@ -9478,7 +9701,7 @@
                 </a:solidFill>
                 <a:latin typeface="Arial Black"/>
               </a:rPr>
-              <a:t>WAS ZEIGEN 108 BEISPIELRECHNUNGEN?</a:t>
+              <a:t>WAS ZEIGEN 10.080 SIMULATIONEN?</a:t>
             </a:r>
           </a:p>
         </p:txBody>
@@ -9776,10 +9999,64 @@
                 </a:solidFill>
                 <a:latin typeface="Arial"/>
               </a:rPr>
-              <a:t>Alte Anlage: 54 / 68 / 80 W
-LED: 18 / 24 / 30 W
-Nutzung: 1.000–6.000 h/Jahr
-Strompreis: 0,25–0,45 €/kWh</a:t>
+              <a:t>Alte Anlage: 40–100 W (5-W-Schritte)</a:t>
+            </a:r>
+          </a:p>
+          <a:p>
+            <a:pPr algn="l">
+              <a:spcBef>
+                <a:spcPts val="0"/>
+              </a:spcBef>
+              <a:spcAft>
+                <a:spcPts val="0"/>
+              </a:spcAft>
+            </a:pPr>
+            <a:r>
+              <a:rPr sz="1400" b="1" i="0">
+                <a:solidFill>
+                  <a:srgbClr val="1B1D1B"/>
+                </a:solidFill>
+                <a:latin typeface="Arial"/>
+              </a:rPr>
+              <a:t>LED: 10–40 W (5-W-Schritte)</a:t>
+            </a:r>
+          </a:p>
+          <a:p>
+            <a:pPr algn="l">
+              <a:spcBef>
+                <a:spcPts val="0"/>
+              </a:spcBef>
+              <a:spcAft>
+                <a:spcPts val="0"/>
+              </a:spcAft>
+            </a:pPr>
+            <a:r>
+              <a:rPr sz="1400" b="1" i="0">
+                <a:solidFill>
+                  <a:srgbClr val="1B1D1B"/>
+                </a:solidFill>
+                <a:latin typeface="Arial"/>
+              </a:rPr>
+              <a:t>Nutzung: 500–8.000 h/Jahr</a:t>
+            </a:r>
+          </a:p>
+          <a:p>
+            <a:pPr algn="l">
+              <a:spcBef>
+                <a:spcPts val="0"/>
+              </a:spcBef>
+              <a:spcAft>
+                <a:spcPts val="0"/>
+              </a:spcAft>
+            </a:pPr>
+            <a:r>
+              <a:rPr sz="1400" b="1" i="0">
+                <a:solidFill>
+                  <a:srgbClr val="1B1D1B"/>
+                </a:solidFill>
+                <a:latin typeface="Arial"/>
+              </a:rPr>
+              <a:t>Strompreis: 0,20–0,50 €/kWh</a:t>
             </a:r>
           </a:p>
         </p:txBody>
@@ -10582,7 +10859,7 @@
                 </a:solidFill>
                 <a:latin typeface="Arial"/>
               </a:rPr>
-              <a:t>Sensitivitätsbereich der 108 Kombinationen: 24–372 kWh bzw. 6,00–167,40 €/Jahr. Modell-Ergebnis, keine Vorhersage.</a:t>
+              <a:t>10.080 gültige Kombinationen (nur Fälle mit weniger LED-Watt): 2,5–720 kWh bzw. 0,50–360,00 €/Jahr. Äußerer Modellbereich, keine typische Erwartung.</a:t>
             </a:r>
           </a:p>
         </p:txBody>

</xml_diff>

<commit_message>
Refine image credits and scenario examples
Co-authored-by: tom948899-jpg <300044775+tom948899-jpg@users.noreply.github.com>
</commit_message>
<xml_diff>
--- a/leuchtstofflampen-praesentation.pptx
+++ b/leuchtstofflampen-praesentation.pptx
@@ -3578,7 +3578,7 @@
                 </a:solidFill>
                 <a:latin typeface="Arial Black"/>
               </a:rPr>
-              <a:t>RETROFIT &amp; ENERGIE</a:t>
+              <a:t>UV-SPEZIALANWENDUNG</a:t>
             </a:r>
           </a:p>
         </p:txBody>
@@ -3620,7 +3620,7 @@
                 </a:solidFill>
                 <a:latin typeface="Arial"/>
               </a:rPr>
-              <a:t>LED kann weniger Strom brauchen – bei passender Lichtmenge und kompatibler Leuchte. Sockel, Vorschaltgerät und Produktangaben vorher prüfen.</a:t>
+              <a:t>Die gezeigte UV-C-Lampe ist keine Raumlicht-LED. Bei Leuchtstofflampen zuerst Lampentyp und Anwendung feststellen.</a:t>
             </a:r>
           </a:p>
         </p:txBody>
@@ -10353,7 +10353,7 @@
                 </a:solidFill>
                 <a:latin typeface="Arial Black"/>
               </a:rPr>
-              <a:t>SPARSAME NUTZUNG</a:t>
+              <a:t>NIEDRIGE NUTZUNG</a:t>
             </a:r>
           </a:p>
         </p:txBody>
@@ -10395,7 +10395,7 @@
                 </a:solidFill>
                 <a:latin typeface="Arial"/>
               </a:rPr>
-              <a:t>24</a:t>
+              <a:t>20</a:t>
             </a:r>
           </a:p>
         </p:txBody>
@@ -10437,7 +10437,7 @@
                 </a:solidFill>
                 <a:latin typeface="Arial Black"/>
               </a:rPr>
-              <a:t>6.00 €</a:t>
+              <a:t>5.00 €</a:t>
             </a:r>
           </a:p>
         </p:txBody>
@@ -10522,7 +10522,7 @@
                 </a:solidFill>
                 <a:latin typeface="Arial Black"/>
               </a:rPr>
-              <a:t>MITTLERES BEISPIEL</a:t>
+              <a:t>MITTLERE NUTZUNG</a:t>
             </a:r>
           </a:p>
         </p:txBody>
@@ -10564,7 +10564,7 @@
                 </a:solidFill>
                 <a:latin typeface="Arial"/>
               </a:rPr>
-              <a:t>110</a:t>
+              <a:t>112,5</a:t>
             </a:r>
           </a:p>
         </p:txBody>
@@ -10606,7 +10606,7 @@
                 </a:solidFill>
                 <a:latin typeface="Arial Black"/>
               </a:rPr>
-              <a:t>38.50 €</a:t>
+              <a:t>39,38 €</a:t>
             </a:r>
           </a:p>
         </p:txBody>
@@ -10733,7 +10733,7 @@
                 </a:solidFill>
                 <a:latin typeface="Arial"/>
               </a:rPr>
-              <a:t>248</a:t>
+              <a:t>340</a:t>
             </a:r>
           </a:p>
         </p:txBody>
@@ -10775,7 +10775,7 @@
                 </a:solidFill>
                 <a:latin typeface="Arial Black"/>
               </a:rPr>
-              <a:t>111.60 €</a:t>
+              <a:t>153,00 €</a:t>
             </a:r>
           </a:p>
         </p:txBody>
@@ -10817,7 +10817,7 @@
                 </a:solidFill>
                 <a:latin typeface="Arial"/>
               </a:rPr>
-              <a:t>Beispiel: (68−24 W) × 2.500 h ÷ 1.000 × 0,35 €/kWh = 38,50 €/Jahr.</a:t>
+              <a:t>Mitte: (70−25 W) × 2.500 h ÷ 1.000 = 112,5 kWh; × 0,35 €/kWh = 39,38 €/Jahr.</a:t>
             </a:r>
           </a:p>
         </p:txBody>

</xml_diff>